<commit_message>
Fix deliverables for final submission.
</commit_message>
<xml_diff>
--- a/deliverables/final_presentation.pptx
+++ b/deliverables/final_presentation.pptx
@@ -3492,7 +3492,7 @@
               <a:defRPr sz="2200"/>
             </a:pPr>
             <a:r>
-              <a:t>Victor Andrade: implementation, CLI workflow, tests, packaging, and analysis integration</a:t>
+              <a:t>Victor Andrade and Ben Miller worked on the project together from start to finish.</a:t>
             </a:r>
           </a:p>
           <a:p>
@@ -3500,7 +3500,7 @@
               <a:defRPr sz="2200"/>
             </a:pPr>
             <a:r>
-              <a:t>Ben Miller: cybersecurity framing, project direction, interpretation goals, and final narrative support</a:t>
+              <a:t>The work was divided evenly across planning, implementation, analysis, reporting, and presentation.</a:t>
             </a:r>
           </a:p>
         </p:txBody>

</xml_diff>